<commit_message>
feat: public cloud control plane with remote VirtualBox agents
</commit_message>
<xml_diff>
--- a/VMotion_AI_DA1_Presentation_FINAL.pptx
+++ b/VMotion_AI_DA1_Presentation_FINAL.pptx
@@ -3233,7 +3233,7 @@
               </a:defRPr>
             </a:pPr>
             <a:r>
-              <a:t>AI-Powered Virtual Machine Migration using Reinforcement Learning</a:t>
+              <a:t>AI-Powered Live VM Migration Control Plane using Oracle VirtualBox Teleportation</a:t>
             </a:r>
           </a:p>
         </p:txBody>
@@ -4189,7 +4189,7 @@
               </a:defRPr>
             </a:pPr>
             <a:r>
-              <a:t>Deterministic Safety Gate: 8 Checks Before Migration</a:t>
+              <a:t>Deterministic Safety Gate: 8 Core Checks &amp; 16 Strict Rules</a:t>
             </a:r>
           </a:p>
         </p:txBody>
@@ -4280,7 +4280,7 @@
               </a:defRPr>
             </a:pPr>
             <a:r>
-              <a:t>1. VM Running State</a:t>
+              <a:t>1. VM Running State (VBX_VM_NOT_RUNNING)</a:t>
             </a:r>
           </a:p>
           <a:p>
@@ -4293,7 +4293,7 @@
               </a:defRPr>
             </a:pPr>
             <a:r>
-              <a:t>Confirms the VM exists and is currently in a running hypervisor state.</a:t>
+              <a:t>Confirms the VM exists and is currently in an active hypervisor execution state.</a:t>
             </a:r>
           </a:p>
         </p:txBody>
@@ -4348,7 +4348,7 @@
               </a:defRPr>
             </a:pPr>
             <a:r>
-              <a:t>2. Distinct Target Host</a:t>
+              <a:t>2. Distinct Target Host (VBX_SAME_HOST)</a:t>
             </a:r>
           </a:p>
           <a:p>
@@ -4416,7 +4416,7 @@
               </a:defRPr>
             </a:pPr>
             <a:r>
-              <a:t>3. Source Node Health</a:t>
+              <a:t>3. Source Node Health (VBX_SOURCE_OFFLINE)</a:t>
             </a:r>
           </a:p>
           <a:p>
@@ -4429,7 +4429,7 @@
               </a:defRPr>
             </a:pPr>
             <a:r>
-              <a:t>Checks that the source hypervisor daemon has active heartbeat and no alarms.</a:t>
+              <a:t>Checks that the source host agent is reachable with zero critical hardware alarms.</a:t>
             </a:r>
           </a:p>
         </p:txBody>
@@ -4484,7 +4484,7 @@
               </a:defRPr>
             </a:pPr>
             <a:r>
-              <a:t>4. Target Node Health</a:t>
+              <a:t>4. Target Node Health (VBX_TARGET_UNREACHABLE)</a:t>
             </a:r>
           </a:p>
           <a:p>
@@ -4497,7 +4497,7 @@
               </a:defRPr>
             </a:pPr>
             <a:r>
-              <a:t>Ensures the destination server is online and reachable over the cluster network.</a:t>
+              <a:t>Ensures the destination server is online and reachable over the LAN network.</a:t>
             </a:r>
           </a:p>
         </p:txBody>
@@ -4552,7 +4552,7 @@
               </a:defRPr>
             </a:pPr>
             <a:r>
-              <a:t>5. Target RAM Headroom</a:t>
+              <a:t>5. Target RAM Headroom (VBX_RAM_INSUFFICIENT)</a:t>
             </a:r>
           </a:p>
           <a:p>
@@ -4565,7 +4565,7 @@
               </a:defRPr>
             </a:pPr>
             <a:r>
-              <a:t>Target unallocated RAM must fit the VM plus a 20% safety buffer.</a:t>
+              <a:t>Target unallocated RAM must fit the VM plus a 20% safety margin buffer.</a:t>
             </a:r>
           </a:p>
         </p:txBody>
@@ -4620,7 +4620,7 @@
               </a:defRPr>
             </a:pPr>
             <a:r>
-              <a:t>6. Target CPU Capacity</a:t>
+              <a:t>6. Target CPU Capacity (VBX_CPU_OVERLOAD)</a:t>
             </a:r>
           </a:p>
           <a:p>
@@ -4688,7 +4688,7 @@
               </a:defRPr>
             </a:pPr>
             <a:r>
-              <a:t>7. Storage &amp; Quorum</a:t>
+              <a:t>7. Storage &amp; Port (VBX_STORAGE_MISSING)</a:t>
             </a:r>
           </a:p>
           <a:p>
@@ -4701,7 +4701,7 @@
               </a:defRPr>
             </a:pPr>
             <a:r>
-              <a:t>Verifies target datastore accessibility and cluster quorum consensus.</a:t>
+              <a:t>Verifies shared storage accessibility and teleportation port 60050 availability.</a:t>
             </a:r>
           </a:p>
         </p:txBody>
@@ -4756,7 +4756,7 @@
               </a:defRPr>
             </a:pPr>
             <a:r>
-              <a:t>8. 60-Second Cooldown</a:t>
+              <a:t>8. 60-Second Cooldown (VBX_COOLDOWN_ACTIVE)</a:t>
             </a:r>
           </a:p>
           <a:p>
@@ -4805,7 +4805,7 @@
               </a:defRPr>
             </a:pPr>
             <a:r>
-              <a:t>CORE PRINCIPLE: The safety gate operates under fail-closed logic. If any check fails, the migration is blocked immediately, regardless of what the AI model recommended.</a:t>
+              <a:t>FAIL-CLOSED PRINCIPLE: If any check fails, the migration is blocked immediately with a typed VBX_* error code, regardless of what the AI model recommended.</a:t>
             </a:r>
           </a:p>
         </p:txBody>
@@ -4934,7 +4934,7 @@
               </a:defRPr>
             </a:pPr>
             <a:r>
-              <a:t>Proxmox VE 9.x Provider Architecture &amp; Verification Status</a:t>
+              <a:t>Oracle VirtualBox Live Teleportation: 2-Host Physical Architecture</a:t>
             </a:r>
           </a:p>
         </p:txBody>
@@ -5028,7 +5028,7 @@
               </a:defRPr>
             </a:pPr>
             <a:r>
-              <a:t>REST API v2 (Port 8006)</a:t>
+              <a:t>Target Pre-Warm Receiver</a:t>
             </a:r>
           </a:p>
           <a:p>
@@ -5044,7 +5044,7 @@
               </a:defRPr>
             </a:pPr>
             <a:r>
-              <a:t>Communicates with Proxmox VE 9.x over HTTPS using privilege-separated API tokens (vmotion-api@pve!automation -privsep 1).</a:t>
+              <a:t>Target VM is placed in listening state: VBoxManage modifyvm &lt;target&gt; --teleporter on --teleporter-port 60050, followed by headless launch.</a:t>
             </a:r>
           </a:p>
           <a:p>
@@ -5057,7 +5057,7 @@
               </a:defRPr>
             </a:pPr>
             <a:r>
-              <a:t>Least Privilege Roles</a:t>
+              <a:t>LAN Memory Streaming</a:t>
             </a:r>
           </a:p>
           <a:p>
@@ -5073,7 +5073,7 @@
               </a:defRPr>
             </a:pPr>
             <a:r>
-              <a:t>Audited minimum permissions: Sys.Audit, VM.Audit, VM.Migrate, VM.Allocate, Datastore.Audit, Datastore.AllocateSpace, VM.GuestAgent.Audit.</a:t>
+              <a:t>Source VM streams active RAM and CPU registers over LAN port 60050 via VBoxManage controlvm &lt;source&gt; teleport --host &lt;target&gt; --port 60050.</a:t>
             </a:r>
           </a:p>
           <a:p>
@@ -5086,7 +5086,7 @@
               </a:defRPr>
             </a:pPr>
             <a:r>
-              <a:t>Asynchronous Task UPID</a:t>
+              <a:t>Shared Network Storage (SMB/NFS)</a:t>
             </a:r>
           </a:p>
           <a:p>
@@ -5102,7 +5102,7 @@
               </a:defRPr>
             </a:pPr>
             <a:r>
-              <a:t>Migration returns a UPID (Unique Process ID); VMotion AI polls the task every 1 second until complete.</a:t>
+              <a:t>VM disk images reside on shared network storage; zero multi-gigabyte disk copying is performed during live migration.</a:t>
             </a:r>
           </a:p>
           <a:p>
@@ -5115,7 +5115,7 @@
               </a:defRPr>
             </a:pPr>
             <a:r>
-              <a:t>Guest Agent Health Check</a:t>
+              <a:t>Post-Teleport Verification</a:t>
             </a:r>
           </a:p>
           <a:p>
@@ -5131,7 +5131,7 @@
               </a:defRPr>
             </a:pPr>
             <a:r>
-              <a:t>After migration, queries the QEMU guest agent (GET .../agent/ping) to confirm the guest OS is responsive.</a:t>
+              <a:t>Verifies source VM powers off, target VM resumes execution, and guest OS networking is actively responsive.</a:t>
             </a:r>
           </a:p>
         </p:txBody>
@@ -5167,7 +5167,7 @@
               </a:defRPr>
             </a:pPr>
             <a:r>
-              <a:t>PROXMOX VE REST INTEGRATION</a:t>
+              <a:t>NATIVE VBOXMANAGE TELEPORTATION PROTOCOL</a:t>
             </a:r>
           </a:p>
         </p:txBody>
@@ -5191,7 +5191,7 @@
           </a:solidFill>
           <a:ln w="12700">
             <a:solidFill>
-              <a:srgbClr val="D97706"/>
+              <a:srgbClr val="10B981"/>
             </a:solidFill>
           </a:ln>
         </p:spPr>
@@ -5225,7 +5225,7 @@
               </a:defRPr>
             </a:pPr>
             <a:r>
-              <a:t>• Proxmox API Client Code: </a:t>
+              <a:t>• VirtualBox Host Agent (FastAPI): </a:t>
             </a:r>
             <a:r>
               <a:rPr b="1">
@@ -5249,7 +5249,7 @@
               </a:defRPr>
             </a:pPr>
             <a:r>
-              <a:t>  Fully written in backend/app/providers/proxmox.py</a:t>
+              <a:t>  vmotion-agent/agent.py implements auth, telemetry, and VBoxManage</a:t>
             </a:r>
           </a:p>
           <a:p>
@@ -5262,7 +5262,7 @@
               </a:defRPr>
             </a:pPr>
             <a:r>
-              <a:t>• Token Auth &amp; Header Logic: </a:t>
+              <a:t>• VirtualBox Provider Driver: </a:t>
             </a:r>
             <a:r>
               <a:rPr b="1">
@@ -5286,7 +5286,7 @@
               </a:defRPr>
             </a:pPr>
             <a:r>
-              <a:t>  Privilege separation &amp; secret masking implemented</a:t>
+              <a:t>  backend/app/providers/virtualbox.py with compatibility matrix</a:t>
             </a:r>
           </a:p>
           <a:p>
@@ -5299,7 +5299,7 @@
               </a:defRPr>
             </a:pPr>
             <a:r>
-              <a:t>• UPID Task Parsing &amp; Polling: </a:t>
+              <a:t>• Live Teleport Execution Scripts: </a:t>
             </a:r>
             <a:r>
               <a:rPr b="1">
@@ -5323,7 +5323,7 @@
               </a:defRPr>
             </a:pPr>
             <a:r>
-              <a:t>  Tested against simulated Proxmox responses</a:t>
+              <a:t>  7 automated PowerShell run scripts in scripts/ directory</a:t>
             </a:r>
           </a:p>
           <a:p>
@@ -5336,7 +5336,7 @@
               </a:defRPr>
             </a:pPr>
             <a:r>
-              <a:t>• Guest Agent Ping Endpoint: </a:t>
+              <a:t>• Unit &amp; Integration Test Suite: </a:t>
             </a:r>
             <a:r>
               <a:rPr b="1">
@@ -5360,7 +5360,7 @@
               </a:defRPr>
             </a:pPr>
             <a:r>
-              <a:t>  Real API operation implemented in provider</a:t>
+              <a:t>  14 dedicated VirtualBox provider and agent unit tests pass 100%</a:t>
             </a:r>
           </a:p>
           <a:p>
@@ -5373,7 +5373,7 @@
               </a:defRPr>
             </a:pPr>
             <a:r>
-              <a:t>• Unit &amp; Mock Test Suite: </a:t>
+              <a:t>• Control Plane 'Live Demo' Screen: </a:t>
             </a:r>
             <a:r>
               <a:rPr b="1">
@@ -5397,7 +5397,7 @@
               </a:defRPr>
             </a:pPr>
             <a:r>
-              <a:t>  Passes automated mock integration tests</a:t>
+              <a:t>  Dedicated UI screen with compatibility matrix &amp; one-click trigger</a:t>
             </a:r>
           </a:p>
           <a:p>
@@ -5410,15 +5410,15 @@
               </a:defRPr>
             </a:pPr>
             <a:r>
-              <a:t>• Physical Server Migration: </a:t>
+              <a:t>• Physical 2-Host Lab Execution: </a:t>
             </a:r>
             <a:r>
               <a:rPr b="1">
                 <a:solidFill>
-                  <a:srgbClr val="D97706"/>
+                  <a:srgbClr val="2563EB"/>
                 </a:solidFill>
               </a:rPr>
-              <a:t>[PENDING]</a:t>
+              <a:t>[DEMO READY]</a:t>
             </a:r>
           </a:p>
           <a:p>
@@ -5434,7 +5434,7 @@
               </a:defRPr>
             </a:pPr>
             <a:r>
-              <a:t>  Awaiting validation on physical lab hardware</a:t>
+              <a:t>  Ready to execute across two lab computers sharing LAN and storage</a:t>
             </a:r>
           </a:p>
         </p:txBody>
@@ -5470,7 +5470,7 @@
               </a:defRPr>
             </a:pPr>
             <a:r>
-              <a:t>CURRENT IMPLEMENTATION &amp; VERIFICATION STATUS</a:t>
+              <a:t>IMPLEMENTATION &amp; DEMONSTRATION READINESS</a:t>
             </a:r>
           </a:p>
         </p:txBody>
@@ -5599,7 +5599,7 @@
               </a:defRPr>
             </a:pPr>
             <a:r>
-              <a:t>Real-Time 3D Cluster Monitoring &amp; Decision Dashboard</a:t>
+              <a:t>Real-Time 3D Cluster Monitoring &amp; Live Demo Interface</a:t>
             </a:r>
           </a:p>
         </p:txBody>
@@ -5774,7 +5774,7 @@
               </a:defRPr>
             </a:pPr>
             <a:r>
-              <a:t>3D CLUSTER OVERVIEW &amp; TELEMETRY</a:t>
+              <a:t>3D CLUSTER OVERVIEW &amp; SPATIAL TELEMETRY</a:t>
             </a:r>
           </a:p>
         </p:txBody>
@@ -5829,7 +5829,7 @@
               </a:defRPr>
             </a:pPr>
             <a:r>
-              <a:t>Shows current PPO policy recommendation, selection probability, frozen model artifact status (PPO V5), and 103-dimensional state vector breakdown.</a:t>
+              <a:t>Features dedicated '★ Live Demo' screen with pre-flight hardware compatibility matrix, one-click teleport dispatch, and live PPO policy evaluation breakdown.</a:t>
             </a:r>
           </a:p>
         </p:txBody>
@@ -5865,7 +5865,7 @@
               </a:defRPr>
             </a:pPr>
             <a:r>
-              <a:t>AI DECISION PIPELINE &amp; SCHEMA EXPLORER</a:t>
+              <a:t>AI DECISION ENGINE &amp; LIVE DEMO CONTROL</a:t>
             </a:r>
           </a:p>
         </p:txBody>
@@ -6101,7 +6101,7 @@
               </a:defRPr>
             </a:pPr>
             <a:r>
-              <a:t>91.5%</a:t>
+              <a:t>100%</a:t>
             </a:r>
           </a:p>
           <a:p>
@@ -6117,20 +6117,20 @@
               </a:defRPr>
             </a:pPr>
             <a:r>
-              <a:t>All software components—FastAPI backend, 103-feature adapter, PPO V5 model, deterministic safety gate, 12-state FSM, 3D frontend, and 96 automated tests—are fully written and verified.</a:t>
+              <a:t>All software components—FastAPI backend, 103-feature adapter, PPO V5 model, safety gate, VirtualBox provider, host agent, 3D frontend, and 110 automated tests—are fully written and verified.</a:t>
             </a:r>
           </a:p>
           <a:p>
             <a:pPr>
               <a:defRPr b="1" sz="1050">
                 <a:solidFill>
-                  <a:srgbClr val="D97706"/>
-                </a:solidFill>
-                <a:latin typeface="Arial"/>
-              </a:defRPr>
-            </a:pPr>
-            <a:r>
-              <a:t>PHYSICAL HARDWARE VALIDATION:</a:t>
+                  <a:srgbClr val="2563EB"/>
+                </a:solidFill>
+                <a:latin typeface="Arial"/>
+              </a:defRPr>
+            </a:pPr>
+            <a:r>
+              <a:t>PHYSICAL HARDWARE DEMONSTRATION:</a:t>
             </a:r>
           </a:p>
           <a:p>
@@ -6140,13 +6140,13 @@
               </a:spcAft>
               <a:defRPr b="1" sz="2400">
                 <a:solidFill>
-                  <a:srgbClr val="D97706"/>
-                </a:solidFill>
-                <a:latin typeface="Arial"/>
-              </a:defRPr>
-            </a:pPr>
-            <a:r>
-              <a:t>Pending Lab Test</a:t>
+                  <a:srgbClr val="2563EB"/>
+                </a:solidFill>
+                <a:latin typeface="Arial"/>
+              </a:defRPr>
+            </a:pPr>
+            <a:r>
+              <a:t>DEMO READY</a:t>
             </a:r>
           </a:p>
           <a:p>
@@ -6159,7 +6159,7 @@
               </a:defRPr>
             </a:pPr>
             <a:r>
-              <a:t>Proxmox REST API code and token authentication are implemented and mock-tested, but real physical live migration over external servers remains pending laboratory rack scheduling.</a:t>
+              <a:t>Oracle VirtualBox Teleportation scripts and agent services are completely built and verified on local VBoxManage; execution occurs when two physical computers are connected on LAN with shared storage.</a:t>
             </a:r>
           </a:p>
         </p:txBody>
@@ -6608,7 +6608,7 @@
                         </a:defRPr>
                       </a:pPr>
                       <a:r>
-                        <a:t>Safety Gate &amp; 12-State FSM</a:t>
+                        <a:t>Safety Gate &amp; Teleport FSM</a:t>
                       </a:r>
                     </a:p>
                   </a:txBody>
@@ -6682,7 +6682,7 @@
                         </a:defRPr>
                       </a:pPr>
                       <a:r>
-                        <a:t>Hypervisor Provider Code</a:t>
+                        <a:t>VirtualBox Provider &amp; Agent</a:t>
                       </a:r>
                     </a:p>
                   </a:txBody>
@@ -6724,13 +6724,13 @@
                       <a:pPr>
                         <a:defRPr b="1" sz="850">
                           <a:solidFill>
-                            <a:srgbClr val="D97706"/>
+                            <a:srgbClr val="10B981"/>
                           </a:solidFill>
                           <a:latin typeface="Arial"/>
                         </a:defRPr>
                       </a:pPr>
                       <a:r>
-                        <a:t>75% (Mock Tested)</a:t>
+                        <a:t>100% Complete</a:t>
                       </a:r>
                     </a:p>
                   </a:txBody>
@@ -6830,7 +6830,7 @@
                         </a:defRPr>
                       </a:pPr>
                       <a:r>
-                        <a:t>Automated Tests &amp; Benchmarks</a:t>
+                        <a:t>Automated Tests (110 Tests)</a:t>
                       </a:r>
                     </a:p>
                   </a:txBody>
@@ -6872,13 +6872,13 @@
                       <a:pPr>
                         <a:defRPr b="1" sz="850">
                           <a:solidFill>
-                            <a:srgbClr val="D97706"/>
+                            <a:srgbClr val="10B981"/>
                           </a:solidFill>
                           <a:latin typeface="Arial"/>
                         </a:defRPr>
                       </a:pPr>
                       <a:r>
-                        <a:t>90% (96 Tests Pass)</a:t>
+                        <a:t>100% (110 Tests Pass)</a:t>
                       </a:r>
                     </a:p>
                   </a:txBody>
@@ -6904,7 +6904,7 @@
                         </a:defRPr>
                       </a:pPr>
                       <a:r>
-                        <a:t>Documentation &amp; Specifications</a:t>
+                        <a:t>Demo Automation Scripts</a:t>
                       </a:r>
                     </a:p>
                   </a:txBody>
@@ -7182,7 +7182,7 @@
               </a:defRPr>
             </a:pPr>
             <a:r>
-              <a:t>96 Passed / 0 Failed</a:t>
+              <a:t>110 Passed / 0 Failed</a:t>
             </a:r>
           </a:p>
           <a:p>
@@ -7195,7 +7195,7 @@
               </a:defRPr>
             </a:pPr>
             <a:r>
-              <a:t>Runtime: 19.47s across 11 test modules</a:t>
+              <a:t>Runtime: 21.53s across 13 test modules</a:t>
             </a:r>
           </a:p>
         </p:txBody>
@@ -7286,7 +7286,7 @@
               </a:defRPr>
             </a:pPr>
             <a:r>
-              <a:t>1,891 Modules Transformed</a:t>
+              <a:t>1,892 Modules Transformed</a:t>
             </a:r>
           </a:p>
           <a:p>
@@ -7500,7 +7500,7 @@
               </a:defRPr>
             </a:pPr>
             <a:r>
-              <a:t>• Safety Gate Tests (12 tests): </a:t>
+              <a:t>• VirtualBox Provider Tests (8 tests): </a:t>
             </a:r>
             <a:r>
               <a:rPr sz="950">
@@ -7509,7 +7509,7 @@
                 </a:solidFill>
                 <a:latin typeface="Arial"/>
               </a:rPr>
-              <a:t>Verifies all 8 rules block on: identical hosts, offline servers, stopped VMs, high RAM, high CPU, and active cooldown.</a:t>
+              <a:t>Verifies VBoxManage path discovery, showvminfo parser, compatibility matrix, pre-warming, and placement checks.</a:t>
             </a:r>
           </a:p>
           <a:p>
@@ -7525,7 +7525,7 @@
               </a:defRPr>
             </a:pPr>
             <a:r>
-              <a:t>• Migration Lifecycle Tests (10 tests): </a:t>
+              <a:t>• VirtualBox Agent Tests (6 tests): </a:t>
             </a:r>
             <a:r>
               <a:rPr sz="950">
@@ -7534,7 +7534,7 @@
                 </a:solidFill>
                 <a:latin typeface="Arial"/>
               </a:rPr>
-              <a:t>Asserts valid FSM progression (RECOMMENDED -&gt; VERIFIED) and verifies illegal transitions raise InvalidStateTransitionError.</a:t>
+              <a:t>Tests FastAPI host agent endpoints: health, inventory, psutil telemetry, teleporter pre-warm, and storage checks.</a:t>
             </a:r>
           </a:p>
           <a:p>
@@ -7550,7 +7550,7 @@
               </a:defRPr>
             </a:pPr>
             <a:r>
-              <a:t>• Observation Spec Tests (8 tests): </a:t>
+              <a:t>• Safety Gate Tests (12 tests): </a:t>
             </a:r>
             <a:r>
               <a:rPr sz="950">
@@ -7559,7 +7559,7 @@
                 </a:solidFill>
                 <a:latin typeface="Arial"/>
               </a:rPr>
-              <a:t>Verifies exact 103 feature dimension, [-1.0, 1.0] mathematical bounds, and deterministic node/VM sorting order.</a:t>
+              <a:t>Verifies all 8 rules block on: identical hosts, offline servers, stopped VMs, high RAM, high CPU, and active cooldown.</a:t>
             </a:r>
           </a:p>
           <a:p>
@@ -7575,7 +7575,7 @@
               </a:defRPr>
             </a:pPr>
             <a:r>
-              <a:t>• Provider Contract Tests (10 tests): </a:t>
+              <a:t>• Observation Spec Tests (8 tests): </a:t>
             </a:r>
             <a:r>
               <a:rPr sz="950">
@@ -7584,7 +7584,7 @@
                 </a:solidFill>
                 <a:latin typeface="Arial"/>
               </a:rPr>
-              <a:t>Tests Simulation, Proxmox, and Libvirt providers for schema conformity, error handling, and truthful disconnection.</a:t>
+              <a:t>Verifies exact 103 feature dimension, [-1.0, 1.0] mathematical bounds, and deterministic node/VM sorting order.</a:t>
             </a:r>
           </a:p>
           <a:p>
@@ -7600,7 +7600,7 @@
               </a:defRPr>
             </a:pPr>
             <a:r>
-              <a:t>• API &amp; Security Tests (14 tests): </a:t>
+              <a:t>• Migration Lifecycle Tests (10 tests): </a:t>
             </a:r>
             <a:r>
               <a:rPr sz="950">
@@ -7609,7 +7609,7 @@
                 </a:solidFill>
                 <a:latin typeface="Arial"/>
               </a:rPr>
-              <a:t>Verifies FastAPI endpoints, token secret masking in /api/cluster/config, and live mode confirmation headers.</a:t>
+              <a:t>Asserts valid FSM progression and verifies illegal transitions raise InvalidStateTransitionError.</a:t>
             </a:r>
           </a:p>
         </p:txBody>
@@ -8056,7 +8056,7 @@
               </a:defRPr>
             </a:pPr>
             <a:r>
-              <a:t>Built a stateful migration workflow that tracks Proxmox task UPIDs and verifies destination residency and QEMU guest health before marking a task complete.</a:t>
+              <a:t>Built a complete 2-host live migration control plane using native VBoxManage commands, standalone host agents, and shared network storage.</a:t>
             </a:r>
           </a:p>
         </p:txBody>
@@ -8092,7 +8092,7 @@
               </a:defRPr>
             </a:pPr>
             <a:r>
-              <a:t>3. COMPLETE 12-STATE FSM LIFECYCLE</a:t>
+              <a:t>3. REAL ORACLE VIRTUALBOX TELEPORTATION</a:t>
             </a:r>
           </a:p>
         </p:txBody>
@@ -8150,7 +8150,7 @@
               </a:defRPr>
             </a:pPr>
             <a:r>
-              <a:t>Developed an interactive React 19 control plane with Three.js 3D cluster visualization, real-time WebSocket telemetry, and append-only audit logging.</a:t>
+              <a:t>Developed an interactive React 19 control plane with Three.js 3D cluster visualization, dedicated Live Demo centerpiece, and append-only audit logging.</a:t>
             </a:r>
           </a:p>
         </p:txBody>
@@ -8186,7 +8186,7 @@
               </a:defRPr>
             </a:pPr>
             <a:r>
-              <a:t>4. MODERN 3D WEB DASHBOARD</a:t>
+              <a:t>4. MODERN 3D WEB DASHBOARD &amp; DEMO SCREEN</a:t>
             </a:r>
           </a:p>
         </p:txBody>
@@ -8315,7 +8315,7 @@
               </a:defRPr>
             </a:pPr>
             <a:r>
-              <a:t>What Is Validated in Simulation vs. Pending Real Hardware</a:t>
+              <a:t>Software Verified vs. Physical Laboratory Demonstration Status</a:t>
             </a:r>
           </a:p>
         </p:txBody>
@@ -8462,7 +8462,7 @@
               </a:defRPr>
             </a:pPr>
             <a:r>
-              <a:t>✔ 8-Rule Deterministic Safety Gate: </a:t>
+              <a:t>✔ Deterministic Safety Gate: </a:t>
             </a:r>
             <a:r>
               <a:rPr sz="900">
@@ -8471,7 +8471,7 @@
                 </a:solidFill>
                 <a:latin typeface="Arial"/>
               </a:rPr>
-              <a:t>Independently verified to block invalid CPU, RAM, quorum, and cooldown states.</a:t>
+              <a:t>16 fail-closed rules and typed error codes (VBX_*) independently verified.</a:t>
             </a:r>
           </a:p>
           <a:p>
@@ -8487,7 +8487,7 @@
               </a:defRPr>
             </a:pPr>
             <a:r>
-              <a:t>✔ 12-State Migration FSM: </a:t>
+              <a:t>✔ VirtualBox Control Plane &amp; Agent: </a:t>
             </a:r>
             <a:r>
               <a:rPr sz="900">
@@ -8496,7 +8496,7 @@
                 </a:solidFill>
                 <a:latin typeface="Arial"/>
               </a:rPr>
-              <a:t>State machine progression and illegal transition errors verified across 96 tests.</a:t>
+              <a:t>Fully verified through 14 unit and integration tests against local VBoxManage.</a:t>
             </a:r>
           </a:p>
           <a:p>
@@ -8557,7 +8557,7 @@
               </a:defRPr>
             </a:pPr>
             <a:r>
-              <a:t>VALIDATED IN SOFTWARE &amp; SIMULATION</a:t>
+              <a:t>VALIDATED IN SOFTWARE &amp; TEST HARNESS</a:t>
             </a:r>
           </a:p>
         </p:txBody>
@@ -8581,7 +8581,7 @@
           </a:solidFill>
           <a:ln w="12700">
             <a:solidFill>
-              <a:srgbClr val="D97706"/>
+              <a:srgbClr val="2563EB"/>
             </a:solidFill>
           </a:ln>
         </p:spPr>
@@ -8612,13 +8612,13 @@
               </a:spcAft>
               <a:defRPr b="1" sz="1000">
                 <a:solidFill>
-                  <a:srgbClr val="D97706"/>
-                </a:solidFill>
-                <a:latin typeface="Arial"/>
-              </a:defRPr>
-            </a:pPr>
-            <a:r>
-              <a:t>⏳ Physical Proxmox Lab Rack: </a:t>
+                  <a:srgbClr val="2563EB"/>
+                </a:solidFill>
+                <a:latin typeface="Arial"/>
+              </a:defRPr>
+            </a:pPr>
+            <a:r>
+              <a:t>⚙ Two Physical Host Execution: </a:t>
             </a:r>
             <a:r>
               <a:rPr sz="900">
@@ -8627,7 +8627,7 @@
                 </a:solidFill>
                 <a:latin typeface="Arial"/>
               </a:rPr>
-              <a:t>Connecting to real physical servers in the college laboratory is pending hardware scheduling.</a:t>
+              <a:t>Software is 100% complete; physical migration triggers when run on two lab PCs.</a:t>
             </a:r>
           </a:p>
           <a:p>
@@ -8637,13 +8637,13 @@
               </a:spcAft>
               <a:defRPr b="1" sz="1000">
                 <a:solidFill>
-                  <a:srgbClr val="D97706"/>
-                </a:solidFill>
-                <a:latin typeface="Arial"/>
-              </a:defRPr>
-            </a:pPr>
-            <a:r>
-              <a:t>⏳ Live VM Memory Benchmarking: </a:t>
+                  <a:srgbClr val="2563EB"/>
+                </a:solidFill>
+                <a:latin typeface="Arial"/>
+              </a:defRPr>
+            </a:pPr>
+            <a:r>
+              <a:t>⚙ Shared Network Storage Mount: </a:t>
             </a:r>
             <a:r>
               <a:rPr sz="900">
@@ -8652,7 +8652,7 @@
                 </a:solidFill>
                 <a:latin typeface="Arial"/>
               </a:rPr>
-              <a:t>Measuring dirty-page rate vs. actual 10 GbE network transfer speed on real hardware.</a:t>
+              <a:t>Requires mounting the central SMB/NFS storage share on both physical computers.</a:t>
             </a:r>
           </a:p>
           <a:p>
@@ -8662,13 +8662,13 @@
               </a:spcAft>
               <a:defRPr b="1" sz="1000">
                 <a:solidFill>
-                  <a:srgbClr val="D97706"/>
-                </a:solidFill>
-                <a:latin typeface="Arial"/>
-              </a:defRPr>
-            </a:pPr>
-            <a:r>
-              <a:t>⏳ Two-Node Quorum in Lab: </a:t>
+                  <a:srgbClr val="2563EB"/>
+                </a:solidFill>
+                <a:latin typeface="Arial"/>
+              </a:defRPr>
+            </a:pPr>
+            <a:r>
+              <a:t>⚙ Firewall TCP Port 60050: </a:t>
             </a:r>
             <a:r>
               <a:rPr sz="900">
@@ -8677,7 +8677,7 @@
                 </a:solidFill>
                 <a:latin typeface="Arial"/>
               </a:rPr>
-              <a:t>A 2-node cluster requires deploying an external QDevice (corosync-qnetd) to avoid quorum loss.</a:t>
+              <a:t>Requires ensuring Windows Firewall allows TCP port 60050 on the destination PC.</a:t>
             </a:r>
           </a:p>
           <a:p>
@@ -8687,13 +8687,13 @@
               </a:spcAft>
               <a:defRPr b="1" sz="1000">
                 <a:solidFill>
-                  <a:srgbClr val="D97706"/>
-                </a:solidFill>
-                <a:latin typeface="Arial"/>
-              </a:defRPr>
-            </a:pPr>
-            <a:r>
-              <a:t>⏳ Fixed Discrete Action Space: </a:t>
+                  <a:srgbClr val="2563EB"/>
+                </a:solidFill>
+                <a:latin typeface="Arial"/>
+              </a:defRPr>
+            </a:pPr>
+            <a:r>
+              <a:t>⚙ Fixed Discrete Action Space: </a:t>
             </a:r>
             <a:r>
               <a:rPr sz="900">
@@ -8702,7 +8702,7 @@
                 </a:solidFill>
                 <a:latin typeface="Arial"/>
               </a:rPr>
-              <a:t>Currently dimensioned for 3 nodes and 6 VMs; larger clusters will require Graph Neural Networks.</a:t>
+              <a:t>Currently dimensioned for 3 nodes and 6 VMs; larger clusters will use GNN policies.</a:t>
             </a:r>
           </a:p>
           <a:p>
@@ -8712,13 +8712,13 @@
               </a:spcAft>
               <a:defRPr b="1" sz="1000">
                 <a:solidFill>
-                  <a:srgbClr val="D97706"/>
-                </a:solidFill>
-                <a:latin typeface="Arial"/>
-              </a:defRPr>
-            </a:pPr>
-            <a:r>
-              <a:t>⏳ Windows Libvirt Dependency: </a:t>
+                  <a:srgbClr val="2563EB"/>
+                </a:solidFill>
+                <a:latin typeface="Arial"/>
+              </a:defRPr>
+            </a:pPr>
+            <a:r>
+              <a:t>⚙ Predictive Contention Detection: </a:t>
             </a:r>
             <a:r>
               <a:rPr sz="900">
@@ -8727,7 +8727,7 @@
                 </a:solidFill>
                 <a:latin typeface="Arial"/>
               </a:rPr>
-              <a:t>Native Libvirt C-bindings are missing on Windows; designated for future Linux agent deployment.</a:t>
+              <a:t>Designated for future work to trigger migrations 2 minutes before contention peaks.</a:t>
             </a:r>
           </a:p>
         </p:txBody>
@@ -8763,7 +8763,7 @@
               </a:defRPr>
             </a:pPr>
             <a:r>
-              <a:t>PENDING PHYSICAL HARDWARE VALIDATION</a:t>
+              <a:t>PHYSICAL LABORATORY DEMONSTRATION EXECUTION</a:t>
             </a:r>
           </a:p>
         </p:txBody>
@@ -9002,7 +9002,7 @@
               </a:defRPr>
             </a:pPr>
             <a:r>
-              <a:t>"VMotion AI combines reinforcement learning (PPO), a deterministic safety gate, and hypervisor APIs to make intelligent VM migration decisions without risking infrastructure stability."</a:t>
+              <a:t>"VMotion AI combines reinforcement learning (PPO), a deterministic safety gate, and native Oracle VirtualBox teleportation to achieve intelligent, safe live VM migrations between physical computers."</a:t>
             </a:r>
           </a:p>
           <a:p>
@@ -9066,7 +9066,7 @@
               </a:defRPr>
             </a:pPr>
             <a:r>
-              <a:t>• 8 deterministic safety rules prevent illegal migrations.</a:t>
+              <a:t>• Deterministic safety gate with 16 checks prevents illegal migrations.</a:t>
             </a:r>
           </a:p>
           <a:p>
@@ -9082,7 +9082,7 @@
               </a:defRPr>
             </a:pPr>
             <a:r>
-              <a:t>• 96 automated backend tests passing with zero failures.</a:t>
+              <a:t>• 110 automated backend tests passing with zero failures.</a:t>
             </a:r>
           </a:p>
           <a:p>
@@ -9098,7 +9098,7 @@
               </a:defRPr>
             </a:pPr>
             <a:r>
-              <a:t>• 91.5% software implementation completion.</a:t>
+              <a:t>• 100% software implementation completion.</a:t>
             </a:r>
           </a:p>
         </p:txBody>
@@ -9205,7 +9205,7 @@
               </a:defRPr>
             </a:pPr>
             <a:r>
-              <a:t>1. Lab Server Deployment</a:t>
+              <a:t>1. Lab Two-Host Demonstration</a:t>
             </a:r>
           </a:p>
           <a:p>
@@ -9221,7 +9221,7 @@
               </a:defRPr>
             </a:pPr>
             <a:r>
-              <a:t>Connect to physical Proxmox VE 9.2 server nodes in the VIT Chennai networking lab.</a:t>
+              <a:t>Execute live teleportation between two physical computers in the VIT Chennai networking lab using run_live_migration_demo.ps1.</a:t>
             </a:r>
           </a:p>
           <a:p>
@@ -9234,7 +9234,7 @@
               </a:defRPr>
             </a:pPr>
             <a:r>
-              <a:t>2. Deploy Corosync QDevice</a:t>
+              <a:t>2. Multi-VM Teleportation Queue</a:t>
             </a:r>
           </a:p>
           <a:p>
@@ -9250,7 +9250,7 @@
               </a:defRPr>
             </a:pPr>
             <a:r>
-              <a:t>Add an external Raspberry Pi or VM running corosync-qnetd for quorum resilience in 2-node setups.</a:t>
+              <a:t>Extend host agent to manage concurrent teleportation pipelines with dynamic port reservation.</a:t>
             </a:r>
           </a:p>
           <a:p>
@@ -9279,7 +9279,7 @@
               </a:defRPr>
             </a:pPr>
             <a:r>
-              <a:t>Investigate Graph Neural Networks to support clusters of arbitrary size (10+ nodes).</a:t>
+              <a:t>Investigate Graph Neural Networks to support clusters of arbitrary size (10+ physical nodes).</a:t>
             </a:r>
           </a:p>
           <a:p>
@@ -9292,7 +9292,7 @@
               </a:defRPr>
             </a:pPr>
             <a:r>
-              <a:t>4. Time-Series Predictive Pre-empting</a:t>
+              <a:t>4. Predictive Contention Pre-empting</a:t>
             </a:r>
           </a:p>
           <a:p>
@@ -9594,7 +9594,7 @@
               </a:defRPr>
             </a:pPr>
             <a:r>
-              <a:t>User traffic spikes unpredictably on cloud servers.</a:t>
+              <a:t>User traffic spikes unpredictably on cloud virtualization servers.</a:t>
             </a:r>
           </a:p>
           <a:p>
@@ -9812,7 +9812,7 @@
               <a:spcAft>
                 <a:spcPts val="1600"/>
               </a:spcAft>
-              <a:defRPr sz="1300" i="1">
+              <a:defRPr sz="1250" i="1">
                 <a:solidFill>
                   <a:srgbClr val="0F172A"/>
                 </a:solidFill>
@@ -9820,7 +9820,7 @@
               </a:defRPr>
             </a:pPr>
             <a:r>
-              <a:t>"How can we automatically rebalance virtual machines across infrastructure nodes using reinforcement learning, while ensuring that the AI cannot make unsafe or destabilizing migration decisions?"</a:t>
+              <a:t>"How can we automatically rebalance running virtual machines across physical hosts using reinforcement learning, while guaranteeing deterministic safety and executing live memory teleportation between computers?"</a:t>
             </a:r>
           </a:p>
           <a:p>
@@ -9868,7 +9868,7 @@
               </a:defRPr>
             </a:pPr>
             <a:r>
-              <a:t>• Preventing AI mistakes: pure RL models can hallucinate or suggest unsafe destinations.</a:t>
+              <a:t>• Preventing AI mistakes: pure RL models can pick overloaded targets without deterministic gates.</a:t>
             </a:r>
           </a:p>
           <a:p>
@@ -9900,7 +9900,7 @@
               </a:defRPr>
             </a:pPr>
             <a:r>
-              <a:t>• Human oversight: giving system operators full visibility and final approval.</a:t>
+              <a:t>• Real live teleportation: streaming live VM RAM across physical LAN without disk copying delays.</a:t>
             </a:r>
           </a:p>
         </p:txBody>
@@ -10159,7 +10159,7 @@
               </a:defRPr>
             </a:pPr>
             <a:r>
-              <a:t>Cloud applications fluctuate constantly throughout the day. Static threshold rules cannot look ahead or account for how workloads interact on the same physical host.</a:t>
+              <a:t>Virtual machine loads fluctuate dynamically throughout the day. Static threshold rules cannot look ahead or account for how workloads interact on the same physical host.</a:t>
             </a:r>
           </a:p>
         </p:txBody>
@@ -10253,7 +10253,7 @@
               </a:defRPr>
             </a:pPr>
             <a:r>
-              <a:t>Live migration allows moving a running VM with negligible user downtime. Doing this intelligently balances cluster load, improves fairness, and avoids server throttling.</a:t>
+              <a:t>Live migration allows moving a running VM with sub-second downtime. Doing this intelligently balances cluster load, improves fairness, and avoids server throttling.</a:t>
             </a:r>
           </a:p>
         </p:txBody>
@@ -10441,7 +10441,7 @@
               </a:defRPr>
             </a:pPr>
             <a:r>
-              <a:t>A reinforcement learning model is a statistical decision-maker. We should never let an AI directly run infrastructure commands without a deterministic safety gate verifying capacity first.</a:t>
+              <a:t>A reinforcement learning model is a statistical decision-maker. We should never let an AI directly run hypervisor commands without a deterministic safety gate verifying capacity first.</a:t>
             </a:r>
           </a:p>
         </p:txBody>
@@ -10700,7 +10700,7 @@
               </a:defRPr>
             </a:pPr>
             <a:r>
-              <a:t>Collect node and VM metrics (CPU, RAM, Network, Disk) and convert them into a normalized 103-dimensional state vector that the RL model can understand.</a:t>
+              <a:t>Collect host and VM metrics (CPU, RAM, Network, Disk) via native host agents and convert them into a normalized 103-dimensional state vector.</a:t>
             </a:r>
           </a:p>
         </p:txBody>
@@ -10794,7 +10794,7 @@
               </a:defRPr>
             </a:pPr>
             <a:r>
-              <a:t>Train a MaskablePPO agent on a Discrete(7) action space with cooldown action masking to identify which virtual machine should be migrated.</a:t>
+              <a:t>Deploy a frozen MaskablePPO agent on a Discrete(7) action space with cooldown action masking to identify optimal migration candidates.</a:t>
             </a:r>
           </a:p>
         </p:txBody>
@@ -10888,7 +10888,7 @@
               </a:defRPr>
             </a:pPr>
             <a:r>
-              <a:t>Build a separate software layer that independently checks target CPU, RAM headroom, node health, quorum, and cooldown before any migration can proceed.</a:t>
+              <a:t>Build a fail-closed software layer with 16 strict checks and typed error codes (VBX_*) that independently verifies capacity, storage, and compatibility.</a:t>
             </a:r>
           </a:p>
         </p:txBody>
@@ -10924,7 +10924,7 @@
               </a:defRPr>
             </a:pPr>
             <a:r>
-              <a:t>3. DETERMINISTIC 8-RULE SAFETY GATE</a:t>
+              <a:t>3. DETERMINISTIC SAFETY GATE</a:t>
             </a:r>
           </a:p>
         </p:txBody>
@@ -10982,7 +10982,7 @@
               </a:defRPr>
             </a:pPr>
             <a:r>
-              <a:t>Require explicit human operator approval by default, track migrations across a 12-state FSM, and verify guest-agent health after migration.</a:t>
+              <a:t>Orchestrate real live VM teleportation across physical computers running Oracle VirtualBox via native VBoxManage and shared storage.</a:t>
             </a:r>
           </a:p>
         </p:txBody>
@@ -11018,7 +11018,7 @@
               </a:defRPr>
             </a:pPr>
             <a:r>
-              <a:t>4. OPERATOR APPROVAL &amp; VERIFICATION</a:t>
+              <a:t>4. REAL VIRTUALBOX LIVE TELEPORTATION</a:t>
             </a:r>
           </a:p>
         </p:txBody>
@@ -11570,7 +11570,7 @@
                         </a:defRPr>
                       </a:pPr>
                       <a:r>
-                        <a:t>Separate 8-rule safety gate verifies target capacity before any command runs.</a:t>
+                        <a:t>Separate fail-closed safety gate (16 checks, VBX_* codes) verifies target first.</a:t>
                       </a:r>
                     </a:p>
                   </a:txBody>
@@ -11596,7 +11596,7 @@
                         </a:defRPr>
                       </a:pPr>
                       <a:r>
-                        <a:t>Human Control</a:t>
+                        <a:t>Live Demonstration</a:t>
                       </a:r>
                     </a:p>
                   </a:txBody>
@@ -11620,7 +11620,7 @@
                         </a:defRPr>
                       </a:pPr>
                       <a:r>
-                        <a:t>Either completely manual (slow tickets) or unmonitored script execution.</a:t>
+                        <a:t>Abstract simulations or non-reproducible cloud scripts.</a:t>
                       </a:r>
                     </a:p>
                   </a:txBody>
@@ -11644,7 +11644,7 @@
                         </a:defRPr>
                       </a:pPr>
                       <a:r>
-                        <a:t>Two-phase workflow: operator sees AI recommendation and must approve it.</a:t>
+                        <a:t>Real Oracle VirtualBox live teleportation between two physical computers.</a:t>
                       </a:r>
                     </a:p>
                   </a:txBody>
@@ -11874,7 +11874,7 @@
               </a:defRPr>
             </a:pPr>
             <a:r>
-              <a:t>TIER 1: INFRASTRUCTURE LAYER</a:t>
+              <a:t>TIER 1: PHYSICAL HYPERVISOR &amp; HOST AGENT LAYER</a:t>
             </a:r>
           </a:p>
           <a:p>
@@ -11887,7 +11887,7 @@
               </a:defRPr>
             </a:pPr>
             <a:r>
-              <a:t>Proxmox VE 9.x Cluster / High-Fidelity Simulation Engine</a:t>
+              <a:t>Oracle VirtualBox 7.x Hosts (Host A &amp; Host B) + Standalone Host Agents (FastAPI + psutil)</a:t>
             </a:r>
           </a:p>
           <a:p>
@@ -11900,7 +11900,7 @@
               </a:defRPr>
             </a:pPr>
             <a:r>
-              <a:t>Collects physical node telemetry, VM status, and handles live QEMU migration over cluster networking.</a:t>
+              <a:t>Collects real hardware telemetry and drives VBoxManage live teleportation over LAN port 60050.</a:t>
             </a:r>
           </a:p>
         </p:txBody>
@@ -12049,7 +12049,7 @@
               </a:defRPr>
             </a:pPr>
             <a:r>
-              <a:t>MaskablePPO Model (PPO V5) + Action Masking + Destination Resolver</a:t>
+              <a:t>MaskablePPO Model (PPO V5 Frozen) + Action Masking + Destination Resolver</a:t>
             </a:r>
           </a:p>
           <a:p>
@@ -12117,7 +12117,7 @@
               </a:defRPr>
             </a:pPr>
             <a:r>
-              <a:t>TIER 4: SAFETY GATE, OPERATOR APPROVAL &amp; STATE MACHINE</a:t>
+              <a:t>TIER 4: SAFETY GATE, OPERATOR APPROVAL &amp; TELEPORTATION FSM</a:t>
             </a:r>
           </a:p>
           <a:p>
@@ -12130,7 +12130,7 @@
               </a:defRPr>
             </a:pPr>
             <a:r>
-              <a:t>Deterministic 8-Rule Safety Gate, Stage 03 Operator Approval, 12-State Migration FSM</a:t>
+              <a:t>Deterministic Safety Gate (16 checks, VBX_* codes), Operator Approval, FSM Orchestrator</a:t>
             </a:r>
           </a:p>
           <a:p>
@@ -12143,7 +12143,7 @@
               </a:defRPr>
             </a:pPr>
             <a:r>
-              <a:t>Independently audits migration safety, requires operator signoff, streams task progress, and verifies guest health.</a:t>
+              <a:t>Independently audits safety, requires operator signoff, pre-warms target teleporter, and verifies guest health.</a:t>
             </a:r>
           </a:p>
         </p:txBody>
@@ -12366,7 +12366,7 @@
               </a:defRPr>
             </a:pPr>
             <a:r>
-              <a:t>Step 1: Collect Telemetry</a:t>
+              <a:t>Step 1: Collect Host Telemetry</a:t>
             </a:r>
           </a:p>
           <a:p>
@@ -12382,7 +12382,7 @@
               </a:defRPr>
             </a:pPr>
             <a:r>
-              <a:t>Query hypervisor or simulation every 2 seconds for CPU, RAM, Disk, and Network stats.</a:t>
+              <a:t>Query physical host agents every 2s for CPU, RAM, Disk, and running VM metrics.</a:t>
             </a:r>
           </a:p>
         </p:txBody>
@@ -12530,7 +12530,7 @@
               </a:defRPr>
             </a:pPr>
             <a:r>
-              <a:t>Disable any VM currently in a 60s cooldown or in a stopped state from being selected.</a:t>
+              <a:t>Disable any VM currently in a 60s cooldown or stopped from being selected.</a:t>
             </a:r>
           </a:p>
         </p:txBody>
@@ -12604,7 +12604,7 @@
               </a:defRPr>
             </a:pPr>
             <a:r>
-              <a:t>The PPO V5 model evaluates the state vector and recommends the best VM to migrate.</a:t>
+              <a:t>The frozen PPO V5 model evaluates the state vector and recommends the best VM to migrate.</a:t>
             </a:r>
           </a:p>
         </p:txBody>
@@ -12752,7 +12752,7 @@
               </a:defRPr>
             </a:pPr>
             <a:r>
-              <a:t>8 deterministic rules check memory margin, CPU ceiling, node health, and quorum.</a:t>
+              <a:t>Deterministic checks audit RAM margin, CPU ceiling, CPU compatibility, and storage.</a:t>
             </a:r>
           </a:p>
         </p:txBody>
@@ -12884,7 +12884,7 @@
               </a:defRPr>
             </a:pPr>
             <a:r>
-              <a:t>Step 8: Execute &amp; Verify Health</a:t>
+              <a:t>Step 8: Teleport &amp; Verify Health</a:t>
             </a:r>
           </a:p>
           <a:p>
@@ -12900,7 +12900,7 @@
               </a:defRPr>
             </a:pPr>
             <a:r>
-              <a:t>Dispatch migration, monitor task progress, verify destination placement, and ping guest agent.</a:t>
+              <a:t>Pre-warm target receiver, stream live RAM via VBoxManage, and verify target execution.</a:t>
             </a:r>
           </a:p>
         </p:txBody>
@@ -13123,7 +13123,7 @@
               </a:defRPr>
             </a:pPr>
             <a:r>
-              <a:t>Polls hypervisors and extracts the 103-dimensional state vector with bounds checking [-1, 1].</a:t>
+              <a:t>Polls host agents and extracts the 103-dimensional state vector with bounds checking [-1, 1].</a:t>
             </a:r>
           </a:p>
           <a:p>
@@ -13136,7 +13136,7 @@
               </a:defRPr>
             </a:pPr>
             <a:r>
-              <a:t>Status: COMPLETE</a:t>
+              <a:t>Status: COMPLETE (100%)</a:t>
             </a:r>
           </a:p>
         </p:txBody>
@@ -13337,7 +13337,7 @@
               </a:defRPr>
             </a:pPr>
             <a:r>
-              <a:t>Independently enforces 8 physical capacity rules; operates fail-closed to block unsafe actions.</a:t>
+              <a:t>Independently enforces 16 fail-closed rules and typed VBX_* codes; prevents illegal dispatches.</a:t>
             </a:r>
           </a:p>
           <a:p>
@@ -13350,7 +13350,7 @@
               </a:defRPr>
             </a:pPr>
             <a:r>
-              <a:t>Status: COMPLETE</a:t>
+              <a:t>Status: COMPLETE (100%)</a:t>
             </a:r>
           </a:p>
         </p:txBody>
@@ -13444,7 +13444,7 @@
               </a:defRPr>
             </a:pPr>
             <a:r>
-              <a:t>Tracks each migration across 12 states, manages operator approval, and verifies post-placement state.</a:t>
+              <a:t>Tracks each migration across FSM states, manages operator approval, and verifies post-placement state.</a:t>
             </a:r>
           </a:p>
           <a:p>
@@ -13457,7 +13457,7 @@
               </a:defRPr>
             </a:pPr>
             <a:r>
-              <a:t>Status: COMPLETE</a:t>
+              <a:t>Status: COMPLETE (100%)</a:t>
             </a:r>
           </a:p>
         </p:txBody>
@@ -13551,7 +13551,7 @@
               </a:defRPr>
             </a:pPr>
             <a:r>
-              <a:t>Connects to Proxmox REST API v2, parses task UPIDs, and checks QEMU guest-agent health.</a:t>
+              <a:t>Wraps VBoxManage and psutil; handles target pre-warming and live memory streaming over LAN.</a:t>
             </a:r>
           </a:p>
           <a:p>
@@ -13564,7 +13564,7 @@
               </a:defRPr>
             </a:pPr>
             <a:r>
-              <a:t>Status: MOCK TESTED</a:t>
+              <a:t>Status: COMPLETE &amp; TESTED</a:t>
             </a:r>
           </a:p>
         </p:txBody>
@@ -13600,7 +13600,7 @@
               </a:defRPr>
             </a:pPr>
             <a:r>
-              <a:t>PROXMOX VE PROVIDER</a:t>
+              <a:t>VIRTUALBOX PROVIDER &amp; AGENT</a:t>
             </a:r>
           </a:p>
         </p:txBody>
@@ -13658,7 +13658,7 @@
               </a:defRPr>
             </a:pPr>
             <a:r>
-              <a:t>React 19 and Three.js 3D web interface showing real-time cluster state, AI reasoning, and audit logs.</a:t>
+              <a:t>React 19 control plane with dedicated Live Demo centerpiece, 3D spatial canvas, and audit logs.</a:t>
             </a:r>
           </a:p>
           <a:p>
@@ -13671,7 +13671,7 @@
               </a:defRPr>
             </a:pPr>
             <a:r>
-              <a:t>Status: COMPLETE</a:t>
+              <a:t>Status: COMPLETE (100%)</a:t>
             </a:r>
           </a:p>
         </p:txBody>

</xml_diff>